<commit_message>
Trim text on smart second-leg slide
Co-Authored-By: Claude Opus 5.5 <noreply@anthropic.com>
Claude-Session: https://claude.ai/code/session_011iFrL2Hfizgp6kYckDtNGc
</commit_message>
<xml_diff>
--- a/智能第二程页.pptx
+++ b/智能第二程页.pptx
@@ -6804,8 +6804,8 @@
         </p:nvSpPr>
         <p:spPr>
           <a:xfrm>
-            <a:off x="685800" y="4370832"/>
-            <a:ext cx="4069080" cy="914400"/>
+            <a:off x="685800" y="4389120"/>
+            <a:ext cx="4069080" cy="685800"/>
           </a:xfrm>
           <a:prstGeom prst="rect">
             <a:avLst/>
@@ -6820,7 +6820,18 @@
           <a:p>
             <a:pPr algn="l"/>
             <a:r>
-              <a:rPr sz="1300" b="0">
+              <a:rPr sz="900" b="0">
+                <a:solidFill>
+                  <a:srgbClr val="287DFA"/>
+                </a:solidFill>
+                <a:latin typeface="微软雅黑"/>
+                <a:ea typeface="微软雅黑"/>
+                <a:cs typeface="微软雅黑"/>
+              </a:rPr>
+              <a:t>●  </a:t>
+            </a:r>
+            <a:r>
+              <a:rPr sz="1400" b="0">
                 <a:solidFill>
                   <a:srgbClr val="3D4757"/>
                 </a:solidFill>
@@ -6828,21 +6839,96 @@
                 <a:ea typeface="微软雅黑"/>
                 <a:cs typeface="微软雅黑"/>
               </a:rPr>
-              <a:t>做到了是惊喜，做不到用户也不会抱怨；但一旦通知了用户、用户也付了款，他就默认一定能出票。</a:t>
+              <a:t>通知 + 付款后，用户默认一定能出票</a:t>
+            </a:r>
+          </a:p>
+          <a:p>
+            <a:pPr algn="l">
+              <a:spcBef>
+                <a:spcPts val="600"/>
+              </a:spcBef>
+            </a:pPr>
+            <a:r>
+              <a:rPr sz="900" b="0">
+                <a:solidFill>
+                  <a:srgbClr val="FF7A1A"/>
+                </a:solidFill>
+                <a:latin typeface="微软雅黑"/>
+                <a:ea typeface="微软雅黑"/>
+                <a:cs typeface="微软雅黑"/>
+              </a:rPr>
+              <a:t>●  </a:t>
+            </a:r>
+            <a:r>
+              <a:rPr sz="1400" b="0">
+                <a:solidFill>
+                  <a:srgbClr val="3D4757"/>
+                </a:solidFill>
+                <a:latin typeface="微软雅黑"/>
+                <a:ea typeface="微软雅黑"/>
+                <a:cs typeface="微软雅黑"/>
+              </a:rPr>
+              <a:t>出票失败，体验比没有这个功能更差</a:t>
             </a:r>
           </a:p>
         </p:txBody>
       </p:sp>
       <p:sp>
         <p:nvSpPr>
-          <p:cNvPr id="29" name="TextBox 28"/>
+          <p:cNvPr id="29" name="Rounded Rectangle 28"/>
+          <p:cNvSpPr/>
+          <p:nvPr/>
+        </p:nvSpPr>
+        <p:spPr>
+          <a:xfrm>
+            <a:off x="685800" y="5303520"/>
+            <a:ext cx="4023360" cy="548640"/>
+          </a:xfrm>
+          <a:prstGeom prst="roundRect">
+            <a:avLst>
+              <a:gd name="adj" fmla="val 30000"/>
+            </a:avLst>
+          </a:prstGeom>
+          <a:solidFill>
+            <a:srgbClr val="FFFFFF"/>
+          </a:solidFill>
+          <a:ln w="12700">
+            <a:solidFill>
+              <a:srgbClr val="287DFA"/>
+            </a:solidFill>
+          </a:ln>
+          <a:effectLst/>
+        </p:spPr>
+        <p:style>
+          <a:lnRef idx="1">
+            <a:schemeClr val="accent1"/>
+          </a:lnRef>
+          <a:fillRef idx="3">
+            <a:schemeClr val="accent1"/>
+          </a:fillRef>
+          <a:effectRef idx="2">
+            <a:schemeClr val="accent1"/>
+          </a:effectRef>
+          <a:fontRef idx="minor">
+            <a:schemeClr val="lt1"/>
+          </a:fontRef>
+        </p:style>
+        <p:txBody>
+          <a:bodyPr rtlCol="0" anchor="ctr"/>
+          <a:lstStyle/>
+          <a:p/>
+        </p:txBody>
+      </p:sp>
+      <p:sp>
+        <p:nvSpPr>
+          <p:cNvPr id="30" name="TextBox 29"/>
           <p:cNvSpPr txBox="1"/>
           <p:nvPr/>
         </p:nvSpPr>
         <p:spPr>
           <a:xfrm>
-            <a:off x="685800" y="5349240"/>
-            <a:ext cx="4069080" cy="640080"/>
+            <a:off x="685800" y="5303520"/>
+            <a:ext cx="4023360" cy="548640"/>
           </a:xfrm>
           <a:prstGeom prst="rect">
             <a:avLst/>
@@ -6850,14 +6936,14 @@
           <a:noFill/>
         </p:spPr>
         <p:txBody>
-          <a:bodyPr wrap="square" lIns="0" rIns="0" tIns="0" bIns="0" anchor="t">
+          <a:bodyPr wrap="square" lIns="0" rIns="0" tIns="0" bIns="0" anchor="ctr">
             <a:spAutoFit/>
           </a:bodyPr>
           <a:lstStyle/>
           <a:p>
-            <a:pPr algn="l"/>
+            <a:pPr algn="ctr"/>
             <a:r>
-              <a:rPr sz="1300" b="1">
+              <a:rPr sz="1400" b="1">
                 <a:solidFill>
                   <a:srgbClr val="287DFA"/>
                 </a:solidFill>
@@ -6868,22 +6954,22 @@
               <a:t>解决方案　</a:t>
             </a:r>
             <a:r>
-              <a:rPr sz="1300" b="0">
+              <a:rPr sz="1400" b="1">
                 <a:solidFill>
-                  <a:srgbClr val="3D4757"/>
+                  <a:srgbClr val="15315E"/>
                 </a:solidFill>
                 <a:latin typeface="微软雅黑"/>
                 <a:ea typeface="微软雅黑"/>
                 <a:cs typeface="微软雅黑"/>
               </a:rPr>
-              <a:t>确认出票的付款统一改为直付，付款成功即可出票</a:t>
+              <a:t>确认出票统一改为直付</a:t>
             </a:r>
           </a:p>
         </p:txBody>
       </p:sp>
       <p:graphicFrame>
         <p:nvGraphicFramePr>
-          <p:cNvPr id="30" name="Chart 29"/>
+          <p:cNvPr id="31" name="Chart 30"/>
           <p:cNvGraphicFramePr>
             <a:graphicFrameLocks noGrp="1"/>
           </p:cNvGraphicFramePr>
@@ -6901,7 +6987,7 @@
       </p:graphicFrame>
       <p:sp>
         <p:nvSpPr>
-          <p:cNvPr id="31" name="Rounded Rectangle 30"/>
+          <p:cNvPr id="32" name="Rounded Rectangle 31"/>
           <p:cNvSpPr/>
           <p:nvPr/>
         </p:nvSpPr>
@@ -6945,7 +7031,7 @@
       </p:sp>
       <p:sp>
         <p:nvSpPr>
-          <p:cNvPr id="32" name="TextBox 31"/>
+          <p:cNvPr id="33" name="TextBox 32"/>
           <p:cNvSpPr txBox="1"/>
           <p:nvPr/>
         </p:nvSpPr>
@@ -7000,7 +7086,7 @@
       </p:sp>
       <p:pic>
         <p:nvPicPr>
-          <p:cNvPr id="33" name="真实截图-车票待确认" descr="second_leg.jpg"/>
+          <p:cNvPr id="34" name="真实截图-车票待确认" descr="second_leg.jpg"/>
           <p:cNvPicPr>
             <a:picLocks noChangeAspect="1"/>
           </p:cNvPicPr>

</xml_diff>